<commit_message>
fix: repair invalid duplicate <a:pPr> in editable PPTX exports (Windows 乱码)
pptxgenjs 4.0.1 emits a duplicate/misplaced <a:pPr> before every text run
in a multi-run paragraph (e.g. a sentence with an inline bold/colored span,
or a list item with inline formatting) instead of once per paragraph. The
resulting OOXML is invalid — PowerPoint for Mac tolerates it silently, but
PowerPoint for Windows repairs it on open and can corrupt the nearby run
text, which showed up as garbled English text (乱码) in decks like
y7-l11, y8-l8, and y7-l12.

Repaired all 44 affected .pptx files in place (verified byte-identical
slide/paragraph/run counts and reconstructed text vs. the originals via
python-pptx — only the invalid duplicate nodes were removed).

Co-Authored-By: Claude Sonnet 5 <noreply@anthropic.com>
</commit_message>
<xml_diff>
--- a/index/designs/y7-l10/l3-half-past/l3-half-past.pptx
+++ b/index/designs/y7-l10/l3-half-past/l3-half-past.pptx
@@ -2492,9 +2492,6 @@
               </a:rPr>
               <a:t>Cumulative Clock Flash · 综合钟表闪卡</a:t>
             </a:r>
-            <a:pPr algn="l" indent="0" marL="0">
-              <a:buNone/>
-            </a:pPr>
             <a:r>
               <a:rPr lang="en-US" sz="600" b="1" dirty="0">
                 <a:solidFill>
@@ -11774,9 +11771,6 @@
               </a:rPr>
               <a:t>Writing Relay · 写字接力</a:t>
             </a:r>
-            <a:pPr algn="ctr" indent="0" marL="0">
-              <a:buNone/>
-            </a:pPr>
             <a:r>
               <a:rPr lang="en-US" sz="600" b="1" dirty="0">
                 <a:solidFill>

</xml_diff>